<commit_message>
PowerPoint Seite 2: Grafiken mit mehr Rand in den Kästen
Co-Authored-By: Claude Opus 5.5 <noreply@anthropic.com>
Claude-Session: https://claude.ai/code/session_01WVrt1ACeGcoC6nYYJLjo6w
</commit_message>
<xml_diff>
--- a/template/Auswertung-Vorlage.pptx
+++ b/template/Auswertung-Vorlage.pptx
@@ -6789,8 +6789,8 @@
         </p:blipFill>
         <p:spPr>
           <a:xfrm>
-            <a:off x="432000" y="2520000"/>
-            <a:ext cx="2808000" cy="2196000"/>
+            <a:off x="576000" y="2556000"/>
+            <a:ext cx="2520000" cy="1969200"/>
           </a:xfrm>
           <a:prstGeom prst="rect">
             <a:avLst/>
@@ -7259,8 +7259,8 @@
         </p:blipFill>
         <p:spPr>
           <a:xfrm>
-            <a:off x="3600000" y="2520000"/>
-            <a:ext cx="2844000" cy="2196000"/>
+            <a:off x="3744000" y="2556000"/>
+            <a:ext cx="2556000" cy="1972800"/>
           </a:xfrm>
           <a:prstGeom prst="rect">
             <a:avLst/>
@@ -8199,8 +8199,8 @@
         </p:blipFill>
         <p:spPr>
           <a:xfrm>
-            <a:off x="468000" y="7488000"/>
-            <a:ext cx="5940000" cy="2160000"/>
+            <a:off x="702000" y="7506000"/>
+            <a:ext cx="5472000" cy="1990800"/>
           </a:xfrm>
           <a:prstGeom prst="rect">
             <a:avLst/>

</xml_diff>